<commit_message>
add weekly reports for 2026-07-10 and updated monthly presentation
</commit_message>
<xml_diff>
--- a/outputs/monthly_presentation.pptx
+++ b/outputs/monthly_presentation.pptx
@@ -3277,14 +3277,9 @@
                   <a:srgbClr val="E8F4FF"/>
                 </a:solidFill>
               </a:rPr>
-              <a:t>Both monitored projects are currently flagged Red with high overall risk, indicating significant challenges across the portfolio.
-TREND_1: Both Outokumpu_S2P and UniSan_S2P are rated Red, signifying critical issues across the entire monitored portfolio.
-TREND_2: Both Outokumpu_S2P and UniSan_S2P are categorized as "High" risk, highlighting pervasive underlying challenges despite varying completion rates.
-TREND_3: Dependency management challenges are evident, with Outokumpu_S2P facing high risk due to critical client actions and UniSan_S2P experiencing significant schedule delays, indicating a common theme of external or internal blockers.
-EMERGING_RISK_1: Systemic schedule health deterioration is apparent, with UniSan_S2P significantly behind schedule and a high number of unstarted tasks, suggesting potential widespread issues in planning or execution.
-EMERGING_RISK_2: Inadequate risk visibility and mitigation capabilities are emerging due to the lack of detailed qualitative commentary from Project Managers, hindering timely identification of root causes and effective resolution strategies.
-EMERGING_RISK_3: Critical client dependency bottlenecks, as seen in Outokumpu_S2P, pose a recurring risk that can stall projects even with internal progress, potentially impacting overall portfolio delivery timelines.
-RECOMMENDATION_1: Mandate immediate, detailed recovery plans from Project Managers for both Outokumpu_S2P and UniSan_S2P,</a:t>
+              <a:t>The portfolio is in a critical state with both monitored projects currently flagged Red and at High Risk, demanding immediate executive attention.
+TREND_1: Both Outokumpu_S2P and UniSan_S2P are universally rated "High" risk, indicating systemic challenges in project execution and external dependencies across the portfolio.
+TREND_2: UniSan_S2P is experiencing significant schedule slippage (14.8% behind) with over 50% of tasks</a:t>
             </a:r>
           </a:p>
         </p:txBody>
@@ -4021,7 +4016,7 @@
               </a:rPr>
               <a:t>PM: N/A  |  Stage: Configuration and Build phase
 Progress: 71%  |  Score: 1.35/2.0
-The Outokumpu_S2P project is currently ahead of its expected completion rate, which is positive. However, it is flagged ...</a:t>
+The Outokumpu_S2P project is at a high risk level despite being ahead on percentage completion. Critical client sign-off...</a:t>
             </a:r>
           </a:p>
         </p:txBody>
@@ -4211,7 +4206,7 @@
               </a:rPr>
               <a:t>PM: N/A  |  Stage: Training Phase I
 Progress: 44%  |  Score: 0.50/2.0
-The UniSan_S2P project is significantly behind schedule, with actual completion at 44% against an expected 58.8%. The pr...</a:t>
+The UniSan_S2P project is currently Red, experiencing significant schedule slippage with a 14.8% gap between actual and ...</a:t>
             </a:r>
           </a:p>
         </p:txBody>
@@ -4545,13 +4540,8 @@
                   <a:srgbClr val="FFFFFF"/>
                 </a:solidFill>
               </a:rPr>
-              <a:t>Both Outokumpu_S2P and UniSan_S2P are rated Red, signifying critical issues across the entire monitored portfolio.
-TREND_2: Both Outokumpu_S2P and UniSan_S2P are categorized as "High" risk, highlighting pervasive underlying challenges despite varying completion rates.
-TREND_3: Dependency management challenges are evident, with Outokumpu_S2P facing high risk due to critical client actions and UniSan_S2P experiencing significant schedule delays, indicating a common theme of external or internal blockers.
-EMERGING_RISK_1: Systemic schedule health deterioration is apparent, with UniSan_S2P significantly behind schedule and a high number of unstarted tasks, suggesting potential widespread issues in planning or execution.
-EMERGING_RISK_2: Inadequate risk visibility and mitigation capabilities are emerging due to the lack of detailed qualitative commentary from Project Managers, hindering timely identification of root causes and effective resolution strategies.
-EMERGING_RISK_3: Critical client dependency bottlenecks, as seen in Outokumpu_S2P, pose a recurring risk that can stall projects even with internal progress, potentially impacting overall portfolio delivery timelines.
-RECOMMENDATION_1: Mandate immediate, detailed recovery plans from Project Managers for both Outokumpu_S2P and UniSan_S2P,</a:t>
+              <a:t>Both Outokumpu_S2P and UniSan_S2P are universally rated "High" risk, indicating systemic challenges in project execution and external dependencies across the portfolio.
+TREND_2: UniSan_S2P is experiencing significant schedule slippage (14.8% behind) with over 50% of tasks</a:t>
             </a:r>
           </a:p>
         </p:txBody>
@@ -4705,56 +4695,42 @@
                   <a:srgbClr val="FFFFFF"/>
                 </a:solidFill>
               </a:rPr>
-              <a:t>Both Outokumpu_S2P and UniSan_S2P are categorized as "High" risk, highlighting pervasive underlying challenges despite varying completion rates.
-TREND_3: Dependency management challenges are evident, with Outokumpu_S2P facing high risk due to critical client actions and UniSan_S2P experiencing significant schedule delays, indicating a common theme of external or internal blockers.
-EMERGING_RISK_1: Systemic schedule health deterioration is apparent, with UniSan_S2P significantly behind schedule and a high number of unstarted tasks, suggesting potential widespread issues in planning or execution.
-EMERGING_RISK_2: Inadequate risk visibility and mitigation capabilities are emerging due to the lack of detailed qualitative commentary from Project Managers, hindering timely identification of root causes and effective resolution strategies.
-EMERGING_RISK_3: Critical client dependency bottlenecks, as seen in Outokumpu_S2P, pose a recurring risk that can stall projects even with internal progress, potentially impacting overall portfolio delivery timelines.
-RECOMMENDATION_1: Mandate immediate, detailed recovery plans from Project Managers for both Outokumpu_S2P and UniSan_S2P,</a:t>
-            </a:r>
-          </a:p>
-        </p:txBody>
-      </p:sp>
-      <p:sp>
-        <p:nvSpPr>
-          <p:cNvPr id="13" name="Rectangle 12"/>
-          <p:cNvSpPr/>
-          <p:nvPr/>
-        </p:nvSpPr>
-        <p:spPr>
-          <a:xfrm>
-            <a:off x="365760" y="3383280"/>
-            <a:ext cx="11338560" cy="914400"/>
-          </a:xfrm>
-          <a:prstGeom prst="rect">
-            <a:avLst/>
-          </a:prstGeom>
-          <a:solidFill>
-            <a:srgbClr val="16213E"/>
-          </a:solidFill>
-          <a:ln>
-            <a:noFill/>
-          </a:ln>
-        </p:spPr>
-        <p:style>
-          <a:lnRef idx="1">
-            <a:schemeClr val="accent1"/>
-          </a:lnRef>
-          <a:fillRef idx="3">
-            <a:schemeClr val="accent1"/>
-          </a:fillRef>
-          <a:effectRef idx="2">
-            <a:schemeClr val="accent1"/>
-          </a:effectRef>
-          <a:fontRef idx="minor">
-            <a:schemeClr val="lt1"/>
-          </a:fontRef>
-        </p:style>
-        <p:txBody>
-          <a:bodyPr rtlCol="0" anchor="ctr"/>
-          <a:lstStyle/>
-          <a:p>
-            <a:pPr algn="ctr"/>
+              <a:t>UniSan_S2P is experiencing significant schedule slippage (14.8% behind) with over 50% of tasks</a:t>
+            </a:r>
+          </a:p>
+        </p:txBody>
+      </p:sp>
+      <p:sp>
+        <p:nvSpPr>
+          <p:cNvPr id="13" name="TextBox 12"/>
+          <p:cNvSpPr txBox="1"/>
+          <p:nvPr/>
+        </p:nvSpPr>
+        <p:spPr>
+          <a:xfrm>
+            <a:off x="457200" y="3474720"/>
+            <a:ext cx="5486400" cy="365760"/>
+          </a:xfrm>
+          <a:prstGeom prst="rect">
+            <a:avLst/>
+          </a:prstGeom>
+          <a:noFill/>
+        </p:spPr>
+        <p:txBody>
+          <a:bodyPr wrap="square">
+            <a:spAutoFit/>
+          </a:bodyPr>
+          <a:lstStyle/>
+          <a:p>
+            <a:pPr algn="l"/>
+            <a:r>
+              <a:rPr sz="1300" b="1" i="0">
+                <a:solidFill>
+                  <a:srgbClr val="E8F4FF"/>
+                </a:solidFill>
+              </a:rPr>
+              <a:t>Project Score Comparison</a:t>
+            </a:r>
           </a:p>
         </p:txBody>
       </p:sp>
@@ -4766,156 +4742,7 @@
         </p:nvSpPr>
         <p:spPr>
           <a:xfrm>
-            <a:off x="365760" y="3383280"/>
-            <a:ext cx="164592" cy="914400"/>
-          </a:xfrm>
-          <a:prstGeom prst="rect">
-            <a:avLst/>
-          </a:prstGeom>
-          <a:solidFill>
-            <a:srgbClr val="0F3E80"/>
-          </a:solidFill>
-          <a:ln>
-            <a:noFill/>
-          </a:ln>
-        </p:spPr>
-        <p:style>
-          <a:lnRef idx="1">
-            <a:schemeClr val="accent1"/>
-          </a:lnRef>
-          <a:fillRef idx="3">
-            <a:schemeClr val="accent1"/>
-          </a:fillRef>
-          <a:effectRef idx="2">
-            <a:schemeClr val="accent1"/>
-          </a:effectRef>
-          <a:fontRef idx="minor">
-            <a:schemeClr val="lt1"/>
-          </a:fontRef>
-        </p:style>
-        <p:txBody>
-          <a:bodyPr rtlCol="0" anchor="ctr"/>
-          <a:lstStyle/>
-          <a:p>
-            <a:pPr algn="ctr"/>
-          </a:p>
-        </p:txBody>
-      </p:sp>
-      <p:sp>
-        <p:nvSpPr>
-          <p:cNvPr id="15" name="TextBox 14"/>
-          <p:cNvSpPr txBox="1"/>
-          <p:nvPr/>
-        </p:nvSpPr>
-        <p:spPr>
-          <a:xfrm>
-            <a:off x="640080" y="3493008"/>
-            <a:ext cx="731520" cy="685800"/>
-          </a:xfrm>
-          <a:prstGeom prst="rect">
-            <a:avLst/>
-          </a:prstGeom>
-          <a:noFill/>
-        </p:spPr>
-        <p:txBody>
-          <a:bodyPr wrap="square">
-            <a:spAutoFit/>
-          </a:bodyPr>
-          <a:lstStyle/>
-          <a:p>
-            <a:pPr algn="l"/>
-            <a:r>
-              <a:rPr sz="2400" b="1" i="0">
-                <a:solidFill>
-                  <a:srgbClr val="0F3E80"/>
-                </a:solidFill>
-              </a:rPr>
-              <a:t>03</a:t>
-            </a:r>
-          </a:p>
-        </p:txBody>
-      </p:sp>
-      <p:sp>
-        <p:nvSpPr>
-          <p:cNvPr id="16" name="TextBox 15"/>
-          <p:cNvSpPr txBox="1"/>
-          <p:nvPr/>
-        </p:nvSpPr>
-        <p:spPr>
-          <a:xfrm>
-            <a:off x="1463040" y="3493008"/>
-            <a:ext cx="10058400" cy="685800"/>
-          </a:xfrm>
-          <a:prstGeom prst="rect">
-            <a:avLst/>
-          </a:prstGeom>
-          <a:noFill/>
-        </p:spPr>
-        <p:txBody>
-          <a:bodyPr wrap="square">
-            <a:spAutoFit/>
-          </a:bodyPr>
-          <a:lstStyle/>
-          <a:p>
-            <a:pPr algn="l"/>
-            <a:r>
-              <a:rPr sz="1200" b="0" i="0">
-                <a:solidFill>
-                  <a:srgbClr val="FFFFFF"/>
-                </a:solidFill>
-              </a:rPr>
-              <a:t>Dependency management challenges are evident, with Outokumpu_S2P facing high risk due to critical client actions and UniSan_S2P experiencing significant schedule delays, indicating a common theme of external or internal blockers.
-EMERGING_RISK_1: Systemic schedule health deterioration is apparent, with UniSan_S2P significantly behind schedule and a high number of unstarted tasks, suggesting potential widespread issues in planning or execution.
-EMERGING_RISK_2: Inadequate risk visibility and mitigation capabilities are emerging due to the lack of detailed qualitative commentary from Project Managers, hindering timely identification of root causes and effective resolution strategies.
-EMERGING_RISK_3: Critical client dependency bottlenecks, as seen in Outokumpu_S2P, pose a recurring risk that can stall projects even with internal progress, potentially impacting overall portfolio delivery timelines.
-RECOMMENDATION_1: Mandate immediate, detailed recovery plans from Project Managers for both Outokumpu_S2P and UniSan_S2P,</a:t>
-            </a:r>
-          </a:p>
-        </p:txBody>
-      </p:sp>
-      <p:sp>
-        <p:nvSpPr>
-          <p:cNvPr id="17" name="TextBox 16"/>
-          <p:cNvSpPr txBox="1"/>
-          <p:nvPr/>
-        </p:nvSpPr>
-        <p:spPr>
-          <a:xfrm>
-            <a:off x="457200" y="4526280"/>
-            <a:ext cx="5486400" cy="365760"/>
-          </a:xfrm>
-          <a:prstGeom prst="rect">
-            <a:avLst/>
-          </a:prstGeom>
-          <a:noFill/>
-        </p:spPr>
-        <p:txBody>
-          <a:bodyPr wrap="square">
-            <a:spAutoFit/>
-          </a:bodyPr>
-          <a:lstStyle/>
-          <a:p>
-            <a:pPr algn="l"/>
-            <a:r>
-              <a:rPr sz="1300" b="1" i="0">
-                <a:solidFill>
-                  <a:srgbClr val="E8F4FF"/>
-                </a:solidFill>
-              </a:rPr>
-              <a:t>Project Score Comparison</a:t>
-            </a:r>
-          </a:p>
-        </p:txBody>
-      </p:sp>
-      <p:sp>
-        <p:nvSpPr>
-          <p:cNvPr id="18" name="Rectangle 17"/>
-          <p:cNvSpPr/>
-          <p:nvPr/>
-        </p:nvSpPr>
-        <p:spPr>
-          <a:xfrm>
-            <a:off x="457200" y="4937760"/>
+            <a:off x="457200" y="3886200"/>
             <a:ext cx="3703320" cy="274320"/>
           </a:xfrm>
           <a:prstGeom prst="rect">
@@ -4952,13 +4779,13 @@
       </p:sp>
       <p:sp>
         <p:nvSpPr>
-          <p:cNvPr id="19" name="TextBox 18"/>
-          <p:cNvSpPr txBox="1"/>
-          <p:nvPr/>
-        </p:nvSpPr>
-        <p:spPr>
-          <a:xfrm>
-            <a:off x="548640" y="4937760"/>
+          <p:cNvPr id="15" name="TextBox 14"/>
+          <p:cNvSpPr txBox="1"/>
+          <p:nvPr/>
+        </p:nvSpPr>
+        <p:spPr>
+          <a:xfrm>
+            <a:off x="548640" y="3886200"/>
             <a:ext cx="6400800" cy="274320"/>
           </a:xfrm>
           <a:prstGeom prst="rect">
@@ -4986,13 +4813,13 @@
       </p:sp>
       <p:sp>
         <p:nvSpPr>
-          <p:cNvPr id="20" name="Rectangle 19"/>
+          <p:cNvPr id="16" name="Rectangle 15"/>
           <p:cNvSpPr/>
           <p:nvPr/>
         </p:nvSpPr>
         <p:spPr>
           <a:xfrm>
-            <a:off x="457200" y="5321808"/>
+            <a:off x="457200" y="4270248"/>
             <a:ext cx="1371600" cy="274320"/>
           </a:xfrm>
           <a:prstGeom prst="rect">
@@ -5029,13 +4856,13 @@
       </p:sp>
       <p:sp>
         <p:nvSpPr>
-          <p:cNvPr id="21" name="TextBox 20"/>
-          <p:cNvSpPr txBox="1"/>
-          <p:nvPr/>
-        </p:nvSpPr>
-        <p:spPr>
-          <a:xfrm>
-            <a:off x="548640" y="5321808"/>
+          <p:cNvPr id="17" name="TextBox 16"/>
+          <p:cNvSpPr txBox="1"/>
+          <p:nvPr/>
+        </p:nvSpPr>
+        <p:spPr>
+          <a:xfrm>
+            <a:off x="548640" y="4270248"/>
             <a:ext cx="6400800" cy="274320"/>
           </a:xfrm>
           <a:prstGeom prst="rect">
@@ -5063,7 +4890,7 @@
       </p:sp>
       <p:sp>
         <p:nvSpPr>
-          <p:cNvPr id="22" name="Rectangle 21"/>
+          <p:cNvPr id="18" name="Rectangle 17"/>
           <p:cNvSpPr/>
           <p:nvPr/>
         </p:nvSpPr>
@@ -5249,8 +5076,8 @@
         </p:nvSpPr>
         <p:spPr>
           <a:xfrm>
-            <a:off x="365760" y="1280160"/>
-            <a:ext cx="11338560" cy="822960"/>
+            <a:off x="365760" y="1371600"/>
+            <a:ext cx="11338560" cy="685800"/>
           </a:xfrm>
           <a:prstGeom prst="rect">
             <a:avLst/>
@@ -5286,91 +5113,14 @@
       </p:sp>
       <p:sp>
         <p:nvSpPr>
-          <p:cNvPr id="6" name="Rectangle 5"/>
-          <p:cNvSpPr/>
-          <p:nvPr/>
-        </p:nvSpPr>
-        <p:spPr>
-          <a:xfrm>
-            <a:off x="365760" y="1280160"/>
-            <a:ext cx="164592" cy="822960"/>
-          </a:xfrm>
-          <a:prstGeom prst="rect">
-            <a:avLst/>
-          </a:prstGeom>
-          <a:solidFill>
-            <a:srgbClr val="C0392B"/>
-          </a:solidFill>
-          <a:ln>
-            <a:noFill/>
-          </a:ln>
-        </p:spPr>
-        <p:style>
-          <a:lnRef idx="1">
-            <a:schemeClr val="accent1"/>
-          </a:lnRef>
-          <a:fillRef idx="3">
-            <a:schemeClr val="accent1"/>
-          </a:fillRef>
-          <a:effectRef idx="2">
-            <a:schemeClr val="accent1"/>
-          </a:effectRef>
-          <a:fontRef idx="minor">
-            <a:schemeClr val="lt1"/>
-          </a:fontRef>
-        </p:style>
-        <p:txBody>
-          <a:bodyPr rtlCol="0" anchor="ctr"/>
-          <a:lstStyle/>
-          <a:p>
-            <a:pPr algn="ctr"/>
-          </a:p>
-        </p:txBody>
-      </p:sp>
-      <p:sp>
-        <p:nvSpPr>
-          <p:cNvPr id="7" name="TextBox 6"/>
-          <p:cNvSpPr txBox="1"/>
-          <p:nvPr/>
-        </p:nvSpPr>
-        <p:spPr>
-          <a:xfrm>
-            <a:off x="594360" y="1353312"/>
-            <a:ext cx="365760" cy="640080"/>
-          </a:xfrm>
-          <a:prstGeom prst="rect">
-            <a:avLst/>
-          </a:prstGeom>
-          <a:noFill/>
-        </p:spPr>
-        <p:txBody>
-          <a:bodyPr wrap="square">
-            <a:spAutoFit/>
-          </a:bodyPr>
-          <a:lstStyle/>
-          <a:p>
-            <a:pPr algn="ctr"/>
-            <a:r>
-              <a:rPr sz="2000" b="1" i="0">
-                <a:solidFill>
-                  <a:srgbClr val="C0392B"/>
-                </a:solidFill>
-              </a:rPr>
-              <a:t>!</a:t>
-            </a:r>
-          </a:p>
-        </p:txBody>
-      </p:sp>
-      <p:sp>
-        <p:nvSpPr>
-          <p:cNvPr id="8" name="TextBox 7"/>
-          <p:cNvSpPr txBox="1"/>
-          <p:nvPr/>
-        </p:nvSpPr>
-        <p:spPr>
-          <a:xfrm>
-            <a:off x="1097280" y="1371600"/>
-            <a:ext cx="10424160" cy="640080"/>
+          <p:cNvPr id="6" name="TextBox 5"/>
+          <p:cNvSpPr txBox="1"/>
+          <p:nvPr/>
+        </p:nvSpPr>
+        <p:spPr>
+          <a:xfrm>
+            <a:off x="640080" y="1444752"/>
+            <a:ext cx="10972800" cy="457200"/>
           </a:xfrm>
           <a:prstGeom prst="rect">
             <a:avLst/>
@@ -5385,397 +5135,6 @@
           <a:p>
             <a:pPr algn="l"/>
             <a:r>
-              <a:rPr sz="1200" b="0" i="0">
-                <a:solidFill>
-                  <a:srgbClr val="FFFFFF"/>
-                </a:solidFill>
-              </a:rPr>
-              <a:t>Systemic schedule health deterioration is apparent, with UniSan_S2P significantly behind schedule and a high number of unstarted tasks, suggesting potential widespread issues in planning or execution.
-EMERGING_RISK_2: Inadequate risk visibility and mitigation capabilities are emerging due to the lack of detailed qualitative commentary from Project Managers, hindering timely identification of root causes and effective resolution strategies.
-EMERGING_RISK_3: Critical client dependency bottlenecks, as seen in Outokumpu_S2P, pose a recurring risk that can stall projects even with internal progress, potentially impacting overall portfolio delivery timelines.
-RECOMMENDATION_1: Mandate immediate, detailed recovery plans from Project Managers for both Outokumpu_S2P and UniSan_S2P,</a:t>
-            </a:r>
-          </a:p>
-        </p:txBody>
-      </p:sp>
-      <p:sp>
-        <p:nvSpPr>
-          <p:cNvPr id="9" name="Rectangle 8"/>
-          <p:cNvSpPr/>
-          <p:nvPr/>
-        </p:nvSpPr>
-        <p:spPr>
-          <a:xfrm>
-            <a:off x="365760" y="2240280"/>
-            <a:ext cx="11338560" cy="822960"/>
-          </a:xfrm>
-          <a:prstGeom prst="rect">
-            <a:avLst/>
-          </a:prstGeom>
-          <a:solidFill>
-            <a:srgbClr val="16213E"/>
-          </a:solidFill>
-          <a:ln>
-            <a:noFill/>
-          </a:ln>
-        </p:spPr>
-        <p:style>
-          <a:lnRef idx="1">
-            <a:schemeClr val="accent1"/>
-          </a:lnRef>
-          <a:fillRef idx="3">
-            <a:schemeClr val="accent1"/>
-          </a:fillRef>
-          <a:effectRef idx="2">
-            <a:schemeClr val="accent1"/>
-          </a:effectRef>
-          <a:fontRef idx="minor">
-            <a:schemeClr val="lt1"/>
-          </a:fontRef>
-        </p:style>
-        <p:txBody>
-          <a:bodyPr rtlCol="0" anchor="ctr"/>
-          <a:lstStyle/>
-          <a:p>
-            <a:pPr algn="ctr"/>
-          </a:p>
-        </p:txBody>
-      </p:sp>
-      <p:sp>
-        <p:nvSpPr>
-          <p:cNvPr id="10" name="Rectangle 9"/>
-          <p:cNvSpPr/>
-          <p:nvPr/>
-        </p:nvSpPr>
-        <p:spPr>
-          <a:xfrm>
-            <a:off x="365760" y="2240280"/>
-            <a:ext cx="164592" cy="822960"/>
-          </a:xfrm>
-          <a:prstGeom prst="rect">
-            <a:avLst/>
-          </a:prstGeom>
-          <a:solidFill>
-            <a:srgbClr val="C0392B"/>
-          </a:solidFill>
-          <a:ln>
-            <a:noFill/>
-          </a:ln>
-        </p:spPr>
-        <p:style>
-          <a:lnRef idx="1">
-            <a:schemeClr val="accent1"/>
-          </a:lnRef>
-          <a:fillRef idx="3">
-            <a:schemeClr val="accent1"/>
-          </a:fillRef>
-          <a:effectRef idx="2">
-            <a:schemeClr val="accent1"/>
-          </a:effectRef>
-          <a:fontRef idx="minor">
-            <a:schemeClr val="lt1"/>
-          </a:fontRef>
-        </p:style>
-        <p:txBody>
-          <a:bodyPr rtlCol="0" anchor="ctr"/>
-          <a:lstStyle/>
-          <a:p>
-            <a:pPr algn="ctr"/>
-          </a:p>
-        </p:txBody>
-      </p:sp>
-      <p:sp>
-        <p:nvSpPr>
-          <p:cNvPr id="11" name="TextBox 10"/>
-          <p:cNvSpPr txBox="1"/>
-          <p:nvPr/>
-        </p:nvSpPr>
-        <p:spPr>
-          <a:xfrm>
-            <a:off x="594360" y="2313432"/>
-            <a:ext cx="365760" cy="640080"/>
-          </a:xfrm>
-          <a:prstGeom prst="rect">
-            <a:avLst/>
-          </a:prstGeom>
-          <a:noFill/>
-        </p:spPr>
-        <p:txBody>
-          <a:bodyPr wrap="square">
-            <a:spAutoFit/>
-          </a:bodyPr>
-          <a:lstStyle/>
-          <a:p>
-            <a:pPr algn="ctr"/>
-            <a:r>
-              <a:rPr sz="2000" b="1" i="0">
-                <a:solidFill>
-                  <a:srgbClr val="C0392B"/>
-                </a:solidFill>
-              </a:rPr>
-              <a:t>!</a:t>
-            </a:r>
-          </a:p>
-        </p:txBody>
-      </p:sp>
-      <p:sp>
-        <p:nvSpPr>
-          <p:cNvPr id="12" name="TextBox 11"/>
-          <p:cNvSpPr txBox="1"/>
-          <p:nvPr/>
-        </p:nvSpPr>
-        <p:spPr>
-          <a:xfrm>
-            <a:off x="1097280" y="2331720"/>
-            <a:ext cx="10424160" cy="640080"/>
-          </a:xfrm>
-          <a:prstGeom prst="rect">
-            <a:avLst/>
-          </a:prstGeom>
-          <a:noFill/>
-        </p:spPr>
-        <p:txBody>
-          <a:bodyPr wrap="square">
-            <a:spAutoFit/>
-          </a:bodyPr>
-          <a:lstStyle/>
-          <a:p>
-            <a:pPr algn="l"/>
-            <a:r>
-              <a:rPr sz="1200" b="0" i="0">
-                <a:solidFill>
-                  <a:srgbClr val="FFFFFF"/>
-                </a:solidFill>
-              </a:rPr>
-              <a:t>Inadequate risk visibility and mitigation capabilities are emerging due to the lack of detailed qualitative commentary from Project Managers, hindering timely identification of root causes and effective resolution strategies.
-EMERGING_RISK_3: Critical client dependency bottlenecks, as seen in Outokumpu_S2P, pose a recurring risk that can stall projects even with internal progress, potentially impacting overall portfolio delivery timelines.
-RECOMMENDATION_1: Mandate immediate, detailed recovery plans from Project Managers for both Outokumpu_S2P and UniSan_S2P,</a:t>
-            </a:r>
-          </a:p>
-        </p:txBody>
-      </p:sp>
-      <p:sp>
-        <p:nvSpPr>
-          <p:cNvPr id="13" name="Rectangle 12"/>
-          <p:cNvSpPr/>
-          <p:nvPr/>
-        </p:nvSpPr>
-        <p:spPr>
-          <a:xfrm>
-            <a:off x="365760" y="3200400"/>
-            <a:ext cx="11338560" cy="822960"/>
-          </a:xfrm>
-          <a:prstGeom prst="rect">
-            <a:avLst/>
-          </a:prstGeom>
-          <a:solidFill>
-            <a:srgbClr val="16213E"/>
-          </a:solidFill>
-          <a:ln>
-            <a:noFill/>
-          </a:ln>
-        </p:spPr>
-        <p:style>
-          <a:lnRef idx="1">
-            <a:schemeClr val="accent1"/>
-          </a:lnRef>
-          <a:fillRef idx="3">
-            <a:schemeClr val="accent1"/>
-          </a:fillRef>
-          <a:effectRef idx="2">
-            <a:schemeClr val="accent1"/>
-          </a:effectRef>
-          <a:fontRef idx="minor">
-            <a:schemeClr val="lt1"/>
-          </a:fontRef>
-        </p:style>
-        <p:txBody>
-          <a:bodyPr rtlCol="0" anchor="ctr"/>
-          <a:lstStyle/>
-          <a:p>
-            <a:pPr algn="ctr"/>
-          </a:p>
-        </p:txBody>
-      </p:sp>
-      <p:sp>
-        <p:nvSpPr>
-          <p:cNvPr id="14" name="Rectangle 13"/>
-          <p:cNvSpPr/>
-          <p:nvPr/>
-        </p:nvSpPr>
-        <p:spPr>
-          <a:xfrm>
-            <a:off x="365760" y="3200400"/>
-            <a:ext cx="164592" cy="822960"/>
-          </a:xfrm>
-          <a:prstGeom prst="rect">
-            <a:avLst/>
-          </a:prstGeom>
-          <a:solidFill>
-            <a:srgbClr val="C0392B"/>
-          </a:solidFill>
-          <a:ln>
-            <a:noFill/>
-          </a:ln>
-        </p:spPr>
-        <p:style>
-          <a:lnRef idx="1">
-            <a:schemeClr val="accent1"/>
-          </a:lnRef>
-          <a:fillRef idx="3">
-            <a:schemeClr val="accent1"/>
-          </a:fillRef>
-          <a:effectRef idx="2">
-            <a:schemeClr val="accent1"/>
-          </a:effectRef>
-          <a:fontRef idx="minor">
-            <a:schemeClr val="lt1"/>
-          </a:fontRef>
-        </p:style>
-        <p:txBody>
-          <a:bodyPr rtlCol="0" anchor="ctr"/>
-          <a:lstStyle/>
-          <a:p>
-            <a:pPr algn="ctr"/>
-          </a:p>
-        </p:txBody>
-      </p:sp>
-      <p:sp>
-        <p:nvSpPr>
-          <p:cNvPr id="15" name="TextBox 14"/>
-          <p:cNvSpPr txBox="1"/>
-          <p:nvPr/>
-        </p:nvSpPr>
-        <p:spPr>
-          <a:xfrm>
-            <a:off x="594360" y="3273552"/>
-            <a:ext cx="365760" cy="640080"/>
-          </a:xfrm>
-          <a:prstGeom prst="rect">
-            <a:avLst/>
-          </a:prstGeom>
-          <a:noFill/>
-        </p:spPr>
-        <p:txBody>
-          <a:bodyPr wrap="square">
-            <a:spAutoFit/>
-          </a:bodyPr>
-          <a:lstStyle/>
-          <a:p>
-            <a:pPr algn="ctr"/>
-            <a:r>
-              <a:rPr sz="2000" b="1" i="0">
-                <a:solidFill>
-                  <a:srgbClr val="C0392B"/>
-                </a:solidFill>
-              </a:rPr>
-              <a:t>!</a:t>
-            </a:r>
-          </a:p>
-        </p:txBody>
-      </p:sp>
-      <p:sp>
-        <p:nvSpPr>
-          <p:cNvPr id="16" name="TextBox 15"/>
-          <p:cNvSpPr txBox="1"/>
-          <p:nvPr/>
-        </p:nvSpPr>
-        <p:spPr>
-          <a:xfrm>
-            <a:off x="1097280" y="3291840"/>
-            <a:ext cx="10424160" cy="640080"/>
-          </a:xfrm>
-          <a:prstGeom prst="rect">
-            <a:avLst/>
-          </a:prstGeom>
-          <a:noFill/>
-        </p:spPr>
-        <p:txBody>
-          <a:bodyPr wrap="square">
-            <a:spAutoFit/>
-          </a:bodyPr>
-          <a:lstStyle/>
-          <a:p>
-            <a:pPr algn="l"/>
-            <a:r>
-              <a:rPr sz="1200" b="0" i="0">
-                <a:solidFill>
-                  <a:srgbClr val="FFFFFF"/>
-                </a:solidFill>
-              </a:rPr>
-              <a:t>Critical client dependency bottlenecks, as seen in Outokumpu_S2P, pose a recurring risk that can stall projects even with internal progress, potentially impacting overall portfolio delivery timelines.
-RECOMMENDATION_1: Mandate immediate, detailed recovery plans from Project Managers for both Outokumpu_S2P and UniSan_S2P,</a:t>
-            </a:r>
-          </a:p>
-        </p:txBody>
-      </p:sp>
-      <p:sp>
-        <p:nvSpPr>
-          <p:cNvPr id="17" name="Rectangle 16"/>
-          <p:cNvSpPr/>
-          <p:nvPr/>
-        </p:nvSpPr>
-        <p:spPr>
-          <a:xfrm>
-            <a:off x="365760" y="4251960"/>
-            <a:ext cx="11338560" cy="685800"/>
-          </a:xfrm>
-          <a:prstGeom prst="rect">
-            <a:avLst/>
-          </a:prstGeom>
-          <a:solidFill>
-            <a:srgbClr val="16213E"/>
-          </a:solidFill>
-          <a:ln>
-            <a:noFill/>
-          </a:ln>
-        </p:spPr>
-        <p:style>
-          <a:lnRef idx="1">
-            <a:schemeClr val="accent1"/>
-          </a:lnRef>
-          <a:fillRef idx="3">
-            <a:schemeClr val="accent1"/>
-          </a:fillRef>
-          <a:effectRef idx="2">
-            <a:schemeClr val="accent1"/>
-          </a:effectRef>
-          <a:fontRef idx="minor">
-            <a:schemeClr val="lt1"/>
-          </a:fontRef>
-        </p:style>
-        <p:txBody>
-          <a:bodyPr rtlCol="0" anchor="ctr"/>
-          <a:lstStyle/>
-          <a:p>
-            <a:pPr algn="ctr"/>
-          </a:p>
-        </p:txBody>
-      </p:sp>
-      <p:sp>
-        <p:nvSpPr>
-          <p:cNvPr id="18" name="TextBox 17"/>
-          <p:cNvSpPr txBox="1"/>
-          <p:nvPr/>
-        </p:nvSpPr>
-        <p:spPr>
-          <a:xfrm>
-            <a:off x="640080" y="4325112"/>
-            <a:ext cx="10972800" cy="457200"/>
-          </a:xfrm>
-          <a:prstGeom prst="rect">
-            <a:avLst/>
-          </a:prstGeom>
-          <a:noFill/>
-        </p:spPr>
-        <p:txBody>
-          <a:bodyPr wrap="square">
-            <a:spAutoFit/>
-          </a:bodyPr>
-          <a:lstStyle/>
-          <a:p>
-            <a:pPr algn="l"/>
-            <a:r>
               <a:rPr sz="1300" b="1" i="0">
                 <a:solidFill>
                   <a:srgbClr val="F39C12"/>
@@ -5788,7 +5147,7 @@
       </p:sp>
       <p:sp>
         <p:nvSpPr>
-          <p:cNvPr id="19" name="Rectangle 18"/>
+          <p:cNvPr id="7" name="Rectangle 6"/>
           <p:cNvSpPr/>
           <p:nvPr/>
         </p:nvSpPr>
@@ -6118,7 +5477,8 @@
               <a:t>PM: N/A
 Stage: Configuration and Build phase
 Progress: 71% (expected ~57%)
-Tasks: 255 done / 467 total</a:t>
+Tasks: 255 done / 467 total
+Top Risk: Critical...</a:t>
             </a:r>
           </a:p>
         </p:txBody>
@@ -6276,7 +5636,7 @@
 Stage: Training Phase I
 Progress: 44% (expected ~59%)
 Tasks: 133 done / 343 total
-Top Risk: Significant schedule slippage (14.8% gap) with over half of the t...</a:t>
+Top Risk: Significant schedule delay: The project is 14.8% behind schedule,...</a:t>
             </a:r>
           </a:p>
         </p:txBody>
@@ -6469,160 +5829,6 @@
         </p:nvSpPr>
         <p:spPr>
           <a:xfrm>
-            <a:off x="365760" y="1280160"/>
-            <a:ext cx="11338560" cy="822960"/>
-          </a:xfrm>
-          <a:prstGeom prst="rect">
-            <a:avLst/>
-          </a:prstGeom>
-          <a:solidFill>
-            <a:srgbClr val="16213E"/>
-          </a:solidFill>
-          <a:ln>
-            <a:noFill/>
-          </a:ln>
-        </p:spPr>
-        <p:style>
-          <a:lnRef idx="1">
-            <a:schemeClr val="accent1"/>
-          </a:lnRef>
-          <a:fillRef idx="3">
-            <a:schemeClr val="accent1"/>
-          </a:fillRef>
-          <a:effectRef idx="2">
-            <a:schemeClr val="accent1"/>
-          </a:effectRef>
-          <a:fontRef idx="minor">
-            <a:schemeClr val="lt1"/>
-          </a:fontRef>
-        </p:style>
-        <p:txBody>
-          <a:bodyPr rtlCol="0" anchor="ctr"/>
-          <a:lstStyle/>
-          <a:p>
-            <a:pPr algn="ctr"/>
-          </a:p>
-        </p:txBody>
-      </p:sp>
-      <p:sp>
-        <p:nvSpPr>
-          <p:cNvPr id="6" name="Rectangle 5"/>
-          <p:cNvSpPr/>
-          <p:nvPr/>
-        </p:nvSpPr>
-        <p:spPr>
-          <a:xfrm>
-            <a:off x="365760" y="1280160"/>
-            <a:ext cx="164592" cy="822960"/>
-          </a:xfrm>
-          <a:prstGeom prst="rect">
-            <a:avLst/>
-          </a:prstGeom>
-          <a:solidFill>
-            <a:srgbClr val="27AE60"/>
-          </a:solidFill>
-          <a:ln>
-            <a:noFill/>
-          </a:ln>
-        </p:spPr>
-        <p:style>
-          <a:lnRef idx="1">
-            <a:schemeClr val="accent1"/>
-          </a:lnRef>
-          <a:fillRef idx="3">
-            <a:schemeClr val="accent1"/>
-          </a:fillRef>
-          <a:effectRef idx="2">
-            <a:schemeClr val="accent1"/>
-          </a:effectRef>
-          <a:fontRef idx="minor">
-            <a:schemeClr val="lt1"/>
-          </a:fontRef>
-        </p:style>
-        <p:txBody>
-          <a:bodyPr rtlCol="0" anchor="ctr"/>
-          <a:lstStyle/>
-          <a:p>
-            <a:pPr algn="ctr"/>
-          </a:p>
-        </p:txBody>
-      </p:sp>
-      <p:sp>
-        <p:nvSpPr>
-          <p:cNvPr id="7" name="TextBox 6"/>
-          <p:cNvSpPr txBox="1"/>
-          <p:nvPr/>
-        </p:nvSpPr>
-        <p:spPr>
-          <a:xfrm>
-            <a:off x="594360" y="1353312"/>
-            <a:ext cx="365760" cy="640080"/>
-          </a:xfrm>
-          <a:prstGeom prst="rect">
-            <a:avLst/>
-          </a:prstGeom>
-          <a:noFill/>
-        </p:spPr>
-        <p:txBody>
-          <a:bodyPr wrap="square">
-            <a:spAutoFit/>
-          </a:bodyPr>
-          <a:lstStyle/>
-          <a:p>
-            <a:pPr algn="ctr"/>
-            <a:r>
-              <a:rPr sz="2000" b="1" i="0">
-                <a:solidFill>
-                  <a:srgbClr val="27AE60"/>
-                </a:solidFill>
-              </a:rPr>
-              <a:t>1</a:t>
-            </a:r>
-          </a:p>
-        </p:txBody>
-      </p:sp>
-      <p:sp>
-        <p:nvSpPr>
-          <p:cNvPr id="8" name="TextBox 7"/>
-          <p:cNvSpPr txBox="1"/>
-          <p:nvPr/>
-        </p:nvSpPr>
-        <p:spPr>
-          <a:xfrm>
-            <a:off x="1097280" y="1371600"/>
-            <a:ext cx="10424160" cy="640080"/>
-          </a:xfrm>
-          <a:prstGeom prst="rect">
-            <a:avLst/>
-          </a:prstGeom>
-          <a:noFill/>
-        </p:spPr>
-        <p:txBody>
-          <a:bodyPr wrap="square">
-            <a:spAutoFit/>
-          </a:bodyPr>
-          <a:lstStyle/>
-          <a:p>
-            <a:pPr algn="l"/>
-            <a:r>
-              <a:rPr sz="1200" b="0" i="0">
-                <a:solidFill>
-                  <a:srgbClr val="FFFFFF"/>
-                </a:solidFill>
-              </a:rPr>
-              <a:t>Mandate immediate, detailed recovery plans from Project Managers for both Outokumpu_S2P and UniSan_S2P,</a:t>
-            </a:r>
-          </a:p>
-        </p:txBody>
-      </p:sp>
-      <p:sp>
-        <p:nvSpPr>
-          <p:cNvPr id="9" name="Rectangle 8"/>
-          <p:cNvSpPr/>
-          <p:nvPr/>
-        </p:nvSpPr>
-        <p:spPr>
-          <a:xfrm>
             <a:off x="0" y="6784848"/>
             <a:ext cx="12188952" cy="73152"/>
           </a:xfrm>
@@ -8033,6 +7239,500 @@
       <p:sp>
         <p:nvSpPr>
           <p:cNvPr id="40" name="Rectangle 39"/>
+          <p:cNvSpPr/>
+          <p:nvPr/>
+        </p:nvSpPr>
+        <p:spPr>
+          <a:xfrm>
+            <a:off x="365760" y="3108960"/>
+            <a:ext cx="11430000" cy="338328"/>
+          </a:xfrm>
+          <a:prstGeom prst="rect">
+            <a:avLst/>
+          </a:prstGeom>
+          <a:solidFill>
+            <a:srgbClr val="1A1A2E"/>
+          </a:solidFill>
+          <a:ln>
+            <a:noFill/>
+          </a:ln>
+        </p:spPr>
+        <p:style>
+          <a:lnRef idx="1">
+            <a:schemeClr val="accent1"/>
+          </a:lnRef>
+          <a:fillRef idx="3">
+            <a:schemeClr val="accent1"/>
+          </a:fillRef>
+          <a:effectRef idx="2">
+            <a:schemeClr val="accent1"/>
+          </a:effectRef>
+          <a:fontRef idx="minor">
+            <a:schemeClr val="lt1"/>
+          </a:fontRef>
+        </p:style>
+        <p:txBody>
+          <a:bodyPr rtlCol="0" anchor="ctr"/>
+          <a:lstStyle/>
+          <a:p>
+            <a:pPr algn="ctr"/>
+          </a:p>
+        </p:txBody>
+      </p:sp>
+      <p:sp>
+        <p:nvSpPr>
+          <p:cNvPr id="41" name="TextBox 40"/>
+          <p:cNvSpPr txBox="1"/>
+          <p:nvPr/>
+        </p:nvSpPr>
+        <p:spPr>
+          <a:xfrm>
+            <a:off x="457200" y="3127248"/>
+            <a:ext cx="2286000" cy="301752"/>
+          </a:xfrm>
+          <a:prstGeom prst="rect">
+            <a:avLst/>
+          </a:prstGeom>
+          <a:noFill/>
+        </p:spPr>
+        <p:txBody>
+          <a:bodyPr wrap="square">
+            <a:spAutoFit/>
+          </a:bodyPr>
+          <a:lstStyle/>
+          <a:p>
+            <a:pPr algn="l"/>
+            <a:r>
+              <a:rPr sz="900" b="0" i="0">
+                <a:solidFill>
+                  <a:srgbClr val="E8F4FF"/>
+                </a:solidFill>
+              </a:rPr>
+              <a:t>2026-07-10</a:t>
+            </a:r>
+          </a:p>
+        </p:txBody>
+      </p:sp>
+      <p:sp>
+        <p:nvSpPr>
+          <p:cNvPr id="42" name="TextBox 41"/>
+          <p:cNvSpPr txBox="1"/>
+          <p:nvPr/>
+        </p:nvSpPr>
+        <p:spPr>
+          <a:xfrm>
+            <a:off x="2926080" y="3127248"/>
+            <a:ext cx="2286000" cy="301752"/>
+          </a:xfrm>
+          <a:prstGeom prst="rect">
+            <a:avLst/>
+          </a:prstGeom>
+          <a:noFill/>
+        </p:spPr>
+        <p:txBody>
+          <a:bodyPr wrap="square">
+            <a:spAutoFit/>
+          </a:bodyPr>
+          <a:lstStyle/>
+          <a:p>
+            <a:pPr algn="l"/>
+            <a:r>
+              <a:rPr sz="900" b="0" i="0">
+                <a:solidFill>
+                  <a:srgbClr val="E8F4FF"/>
+                </a:solidFill>
+              </a:rPr>
+              <a:t>Outokumpu S2P</a:t>
+            </a:r>
+          </a:p>
+        </p:txBody>
+      </p:sp>
+      <p:sp>
+        <p:nvSpPr>
+          <p:cNvPr id="43" name="TextBox 42"/>
+          <p:cNvSpPr txBox="1"/>
+          <p:nvPr/>
+        </p:nvSpPr>
+        <p:spPr>
+          <a:xfrm>
+            <a:off x="5029200" y="3127248"/>
+            <a:ext cx="2286000" cy="301752"/>
+          </a:xfrm>
+          <a:prstGeom prst="rect">
+            <a:avLst/>
+          </a:prstGeom>
+          <a:noFill/>
+        </p:spPr>
+        <p:txBody>
+          <a:bodyPr wrap="square">
+            <a:spAutoFit/>
+          </a:bodyPr>
+          <a:lstStyle/>
+          <a:p>
+            <a:pPr algn="l"/>
+            <a:r>
+              <a:rPr sz="900" b="0" i="0">
+                <a:solidFill>
+                  <a:srgbClr val="C0392B"/>
+                </a:solidFill>
+              </a:rPr>
+              <a:t>Red</a:t>
+            </a:r>
+          </a:p>
+        </p:txBody>
+      </p:sp>
+      <p:sp>
+        <p:nvSpPr>
+          <p:cNvPr id="44" name="TextBox 43"/>
+          <p:cNvSpPr txBox="1"/>
+          <p:nvPr/>
+        </p:nvSpPr>
+        <p:spPr>
+          <a:xfrm>
+            <a:off x="6675120" y="3127248"/>
+            <a:ext cx="2286000" cy="301752"/>
+          </a:xfrm>
+          <a:prstGeom prst="rect">
+            <a:avLst/>
+          </a:prstGeom>
+          <a:noFill/>
+        </p:spPr>
+        <p:txBody>
+          <a:bodyPr wrap="square">
+            <a:spAutoFit/>
+          </a:bodyPr>
+          <a:lstStyle/>
+          <a:p>
+            <a:pPr algn="l"/>
+            <a:r>
+              <a:rPr sz="900" b="0" i="0">
+                <a:solidFill>
+                  <a:srgbClr val="E8F4FF"/>
+                </a:solidFill>
+              </a:rPr>
+              <a:t>1.35</a:t>
+            </a:r>
+          </a:p>
+        </p:txBody>
+      </p:sp>
+      <p:sp>
+        <p:nvSpPr>
+          <p:cNvPr id="45" name="TextBox 44"/>
+          <p:cNvSpPr txBox="1"/>
+          <p:nvPr/>
+        </p:nvSpPr>
+        <p:spPr>
+          <a:xfrm>
+            <a:off x="8686800" y="3127248"/>
+            <a:ext cx="2286000" cy="301752"/>
+          </a:xfrm>
+          <a:prstGeom prst="rect">
+            <a:avLst/>
+          </a:prstGeom>
+          <a:noFill/>
+        </p:spPr>
+        <p:txBody>
+          <a:bodyPr wrap="square">
+            <a:spAutoFit/>
+          </a:bodyPr>
+          <a:lstStyle/>
+          <a:p>
+            <a:pPr algn="l"/>
+            <a:r>
+              <a:rPr sz="900" b="0" i="0">
+                <a:solidFill>
+                  <a:srgbClr val="E8F4FF"/>
+                </a:solidFill>
+              </a:rPr>
+              <a:t>71%</a:t>
+            </a:r>
+          </a:p>
+        </p:txBody>
+      </p:sp>
+      <p:sp>
+        <p:nvSpPr>
+          <p:cNvPr id="46" name="TextBox 45"/>
+          <p:cNvSpPr txBox="1"/>
+          <p:nvPr/>
+        </p:nvSpPr>
+        <p:spPr>
+          <a:xfrm>
+            <a:off x="10241280" y="3127248"/>
+            <a:ext cx="2286000" cy="301752"/>
+          </a:xfrm>
+          <a:prstGeom prst="rect">
+            <a:avLst/>
+          </a:prstGeom>
+          <a:noFill/>
+        </p:spPr>
+        <p:txBody>
+          <a:bodyPr wrap="square">
+            <a:spAutoFit/>
+          </a:bodyPr>
+          <a:lstStyle/>
+          <a:p>
+            <a:pPr algn="l"/>
+            <a:r>
+              <a:rPr sz="900" b="0" i="0">
+                <a:solidFill>
+                  <a:srgbClr val="E8F4FF"/>
+                </a:solidFill>
+              </a:rPr>
+              <a:t>High</a:t>
+            </a:r>
+          </a:p>
+        </p:txBody>
+      </p:sp>
+      <p:sp>
+        <p:nvSpPr>
+          <p:cNvPr id="47" name="Rectangle 46"/>
+          <p:cNvSpPr/>
+          <p:nvPr/>
+        </p:nvSpPr>
+        <p:spPr>
+          <a:xfrm>
+            <a:off x="365760" y="3474720"/>
+            <a:ext cx="11430000" cy="338328"/>
+          </a:xfrm>
+          <a:prstGeom prst="rect">
+            <a:avLst/>
+          </a:prstGeom>
+          <a:solidFill>
+            <a:srgbClr val="16213E"/>
+          </a:solidFill>
+          <a:ln>
+            <a:noFill/>
+          </a:ln>
+        </p:spPr>
+        <p:style>
+          <a:lnRef idx="1">
+            <a:schemeClr val="accent1"/>
+          </a:lnRef>
+          <a:fillRef idx="3">
+            <a:schemeClr val="accent1"/>
+          </a:fillRef>
+          <a:effectRef idx="2">
+            <a:schemeClr val="accent1"/>
+          </a:effectRef>
+          <a:fontRef idx="minor">
+            <a:schemeClr val="lt1"/>
+          </a:fontRef>
+        </p:style>
+        <p:txBody>
+          <a:bodyPr rtlCol="0" anchor="ctr"/>
+          <a:lstStyle/>
+          <a:p>
+            <a:pPr algn="ctr"/>
+          </a:p>
+        </p:txBody>
+      </p:sp>
+      <p:sp>
+        <p:nvSpPr>
+          <p:cNvPr id="48" name="TextBox 47"/>
+          <p:cNvSpPr txBox="1"/>
+          <p:nvPr/>
+        </p:nvSpPr>
+        <p:spPr>
+          <a:xfrm>
+            <a:off x="457200" y="3493008"/>
+            <a:ext cx="2286000" cy="301752"/>
+          </a:xfrm>
+          <a:prstGeom prst="rect">
+            <a:avLst/>
+          </a:prstGeom>
+          <a:noFill/>
+        </p:spPr>
+        <p:txBody>
+          <a:bodyPr wrap="square">
+            <a:spAutoFit/>
+          </a:bodyPr>
+          <a:lstStyle/>
+          <a:p>
+            <a:pPr algn="l"/>
+            <a:r>
+              <a:rPr sz="900" b="0" i="0">
+                <a:solidFill>
+                  <a:srgbClr val="E8F4FF"/>
+                </a:solidFill>
+              </a:rPr>
+              <a:t>2026-07-10</a:t>
+            </a:r>
+          </a:p>
+        </p:txBody>
+      </p:sp>
+      <p:sp>
+        <p:nvSpPr>
+          <p:cNvPr id="49" name="TextBox 48"/>
+          <p:cNvSpPr txBox="1"/>
+          <p:nvPr/>
+        </p:nvSpPr>
+        <p:spPr>
+          <a:xfrm>
+            <a:off x="2926080" y="3493008"/>
+            <a:ext cx="2286000" cy="301752"/>
+          </a:xfrm>
+          <a:prstGeom prst="rect">
+            <a:avLst/>
+          </a:prstGeom>
+          <a:noFill/>
+        </p:spPr>
+        <p:txBody>
+          <a:bodyPr wrap="square">
+            <a:spAutoFit/>
+          </a:bodyPr>
+          <a:lstStyle/>
+          <a:p>
+            <a:pPr algn="l"/>
+            <a:r>
+              <a:rPr sz="900" b="0" i="0">
+                <a:solidFill>
+                  <a:srgbClr val="E8F4FF"/>
+                </a:solidFill>
+              </a:rPr>
+              <a:t>UniSan S2P</a:t>
+            </a:r>
+          </a:p>
+        </p:txBody>
+      </p:sp>
+      <p:sp>
+        <p:nvSpPr>
+          <p:cNvPr id="50" name="TextBox 49"/>
+          <p:cNvSpPr txBox="1"/>
+          <p:nvPr/>
+        </p:nvSpPr>
+        <p:spPr>
+          <a:xfrm>
+            <a:off x="5029200" y="3493008"/>
+            <a:ext cx="2286000" cy="301752"/>
+          </a:xfrm>
+          <a:prstGeom prst="rect">
+            <a:avLst/>
+          </a:prstGeom>
+          <a:noFill/>
+        </p:spPr>
+        <p:txBody>
+          <a:bodyPr wrap="square">
+            <a:spAutoFit/>
+          </a:bodyPr>
+          <a:lstStyle/>
+          <a:p>
+            <a:pPr algn="l"/>
+            <a:r>
+              <a:rPr sz="900" b="0" i="0">
+                <a:solidFill>
+                  <a:srgbClr val="C0392B"/>
+                </a:solidFill>
+              </a:rPr>
+              <a:t>Red</a:t>
+            </a:r>
+          </a:p>
+        </p:txBody>
+      </p:sp>
+      <p:sp>
+        <p:nvSpPr>
+          <p:cNvPr id="51" name="TextBox 50"/>
+          <p:cNvSpPr txBox="1"/>
+          <p:nvPr/>
+        </p:nvSpPr>
+        <p:spPr>
+          <a:xfrm>
+            <a:off x="6675120" y="3493008"/>
+            <a:ext cx="2286000" cy="301752"/>
+          </a:xfrm>
+          <a:prstGeom prst="rect">
+            <a:avLst/>
+          </a:prstGeom>
+          <a:noFill/>
+        </p:spPr>
+        <p:txBody>
+          <a:bodyPr wrap="square">
+            <a:spAutoFit/>
+          </a:bodyPr>
+          <a:lstStyle/>
+          <a:p>
+            <a:pPr algn="l"/>
+            <a:r>
+              <a:rPr sz="900" b="0" i="0">
+                <a:solidFill>
+                  <a:srgbClr val="E8F4FF"/>
+                </a:solidFill>
+              </a:rPr>
+              <a:t>0.50</a:t>
+            </a:r>
+          </a:p>
+        </p:txBody>
+      </p:sp>
+      <p:sp>
+        <p:nvSpPr>
+          <p:cNvPr id="52" name="TextBox 51"/>
+          <p:cNvSpPr txBox="1"/>
+          <p:nvPr/>
+        </p:nvSpPr>
+        <p:spPr>
+          <a:xfrm>
+            <a:off x="8686800" y="3493008"/>
+            <a:ext cx="2286000" cy="301752"/>
+          </a:xfrm>
+          <a:prstGeom prst="rect">
+            <a:avLst/>
+          </a:prstGeom>
+          <a:noFill/>
+        </p:spPr>
+        <p:txBody>
+          <a:bodyPr wrap="square">
+            <a:spAutoFit/>
+          </a:bodyPr>
+          <a:lstStyle/>
+          <a:p>
+            <a:pPr algn="l"/>
+            <a:r>
+              <a:rPr sz="900" b="0" i="0">
+                <a:solidFill>
+                  <a:srgbClr val="E8F4FF"/>
+                </a:solidFill>
+              </a:rPr>
+              <a:t>44%</a:t>
+            </a:r>
+          </a:p>
+        </p:txBody>
+      </p:sp>
+      <p:sp>
+        <p:nvSpPr>
+          <p:cNvPr id="53" name="TextBox 52"/>
+          <p:cNvSpPr txBox="1"/>
+          <p:nvPr/>
+        </p:nvSpPr>
+        <p:spPr>
+          <a:xfrm>
+            <a:off x="10241280" y="3493008"/>
+            <a:ext cx="2286000" cy="301752"/>
+          </a:xfrm>
+          <a:prstGeom prst="rect">
+            <a:avLst/>
+          </a:prstGeom>
+          <a:noFill/>
+        </p:spPr>
+        <p:txBody>
+          <a:bodyPr wrap="square">
+            <a:spAutoFit/>
+          </a:bodyPr>
+          <a:lstStyle/>
+          <a:p>
+            <a:pPr algn="l"/>
+            <a:r>
+              <a:rPr sz="900" b="0" i="0">
+                <a:solidFill>
+                  <a:srgbClr val="E8F4FF"/>
+                </a:solidFill>
+              </a:rPr>
+              <a:t>High</a:t>
+            </a:r>
+          </a:p>
+        </p:txBody>
+      </p:sp>
+      <p:sp>
+        <p:nvSpPr>
+          <p:cNvPr id="54" name="Rectangle 53"/>
           <p:cNvSpPr/>
           <p:nvPr/>
         </p:nvSpPr>

</xml_diff>